<commit_message>
Slides: remove em/en dashes from visible text
</commit_message>
<xml_diff>
--- a/photic_milestone_slides.pptx
+++ b/photic_milestone_slides.pptx
@@ -680,7 +680,7 @@
           <a:p>
             <a:r>
               <a:rPr lang="en-US" dirty="0"/>
-              <a:t>Here's the main result. The Kd we measured is about a third lower than what the simple no-scattering math predicts. That's the whole point: when light scatters it doesn't just vanish, a lot of it comes back into view, so the water fades slower than the naive number says. And the gap is biggest for blue and smallest for red, which lines up with how much each color scatters versus absorbs — we never told it to do that, so the color side is working. A few things are still rough, like the isotropic scattering and the ballpark coefficients, and next week we add the real Henyey-Greenstein scattering, a Secchi-disk test, and a convergence study.</a:t>
+              <a:t>Here's the main result. The Kd we measured is about a third lower than what the simple no-scattering math predicts. That's the whole point: when light scatters it doesn't just vanish, a lot of it comes back into view, so the water fades slower than the naive number says. And the gap is biggest for blue and smallest for red, which lines up with how much each color scatters versus absorbs, and we never told it to do that, so the color side is working. A few things are still rough, like the isotropic scattering and the ballpark coefficients, and next week we add the real Henyey-Greenstein scattering, a Secchi-disk test, and a convergence study.</a:t>
             </a:r>
             <a:endParaRPr lang="en-US" dirty="0"/>
           </a:p>
@@ -1713,7 +1713,7 @@
                 <a:ea typeface="Calibri" pitchFamily="34" charset="-122"/>
                 <a:cs typeface="Calibri" pitchFamily="34" charset="-120"/>
               </a:rPr>
-              <a:t>HW3 — no water</a:t>
+              <a:t>HW3, no water</a:t>
             </a:r>
             <a:endParaRPr lang="en-US" sz="1100" dirty="0"/>
           </a:p>
@@ -1886,7 +1886,7 @@
                 <a:ea typeface="Calibri" pitchFamily="34" charset="-122"/>
                 <a:cs typeface="Calibri" pitchFamily="34" charset="-120"/>
               </a:rPr>
-              <a:t>The water fades slower than the simple math predicts — on every color channel.</a:t>
+              <a:t>The water fades slower than the simple math predicts, on every color channel.</a:t>
             </a:r>
             <a:endParaRPr lang="en-US" sz="1600" dirty="0"/>
           </a:p>
@@ -1947,7 +1947,7 @@
                 <a:ea typeface="Calibri" pitchFamily="34" charset="-122"/>
                 <a:cs typeface="Calibri" pitchFamily="34" charset="-120"/>
               </a:rPr>
-              <a:t>33–36%</a:t>
+              <a:t>33-36%</a:t>
             </a:r>
             <a:endParaRPr lang="en-US" sz="4600" dirty="0"/>
           </a:p>
@@ -3221,7 +3221,7 @@
                 <a:ea typeface="Calibri" pitchFamily="34" charset="-122"/>
                 <a:cs typeface="Calibri" pitchFamily="34" charset="-120"/>
               </a:rPr>
-              <a:t>The gap is biggest for blue and smallest for red, matching how much each color scatters versus absorbs. We didn't code that ordering in — it came out on its own.</a:t>
+              <a:t>The gap is biggest for blue and smallest for red, matching how much each color scatters versus absorbs. We didn't code that ordering in, it came out on its own.</a:t>
             </a:r>
             <a:endParaRPr lang="en-US" sz="1250" dirty="0"/>
           </a:p>
@@ -3321,7 +3321,7 @@
                 <a:ea typeface="Calibri" pitchFamily="34" charset="-122"/>
                 <a:cs typeface="Calibri" pitchFamily="34" charset="-120"/>
               </a:rPr>
-              <a:t>Real Henyey–Greenstein scattering, a Secchi-disk test, and a convergence study.</a:t>
+              <a:t>Real Henyey-Greenstein scattering, a Secchi-disk test, and a convergence study.</a:t>
             </a:r>
             <a:endParaRPr lang="en-US" sz="1200" dirty="0"/>
           </a:p>

</xml_diff>